<commit_message>
Add team members and institution to paper, report and slides
Authors ordered by roll number (016, 021, 028, 035), Dept. of CSE, Amrita Vishwa Vidyapeetham, Amaravati Campus.

Co-Authored-By: Claude Opus 5.5 <noreply@anthropic.com>
</commit_message>
<xml_diff>
--- a/presentation/Digital_Manufacturing_ABS_Presentation.pptx
+++ b/presentation/Digital_Manufacturing_ABS_Presentation.pptx
@@ -3572,7 +3572,7 @@
                 </a:solidFill>
                 <a:latin typeface="Calibri"/>
               </a:rPr>
-              <a:t>Roll numbers: 016, 021, 028, 035</a:t>
+              <a:t>016  Gedela Kiran Kumar</a:t>
             </a:r>
           </a:p>
           <a:p>
@@ -3588,7 +3588,7 @@
                 </a:solidFill>
                 <a:latin typeface="Calibri"/>
               </a:rPr>
-              <a:t>[add team member names]</a:t>
+              <a:t>021  Kapuluru Chenchu Sai Sashank</a:t>
             </a:r>
           </a:p>
           <a:p>
@@ -3604,7 +3604,39 @@
                 </a:solidFill>
                 <a:latin typeface="Calibri"/>
               </a:rPr>
-              <a:t>Final Review</a:t>
+              <a:t>028  Sai Mani</a:t>
+            </a:r>
+          </a:p>
+          <a:p>
+            <a:pPr algn="l">
+              <a:spcAft>
+                <a:spcPts val="400"/>
+              </a:spcAft>
+            </a:pPr>
+            <a:r>
+              <a:rPr sz="1100" b="0" i="0">
+                <a:solidFill>
+                  <a:srgbClr val="FFFFFF"/>
+                </a:solidFill>
+                <a:latin typeface="Calibri"/>
+              </a:rPr>
+              <a:t>035  Perumalla Krishna Murthy</a:t>
+            </a:r>
+          </a:p>
+          <a:p>
+            <a:pPr algn="l">
+              <a:spcAft>
+                <a:spcPts val="400"/>
+              </a:spcAft>
+            </a:pPr>
+            <a:r>
+              <a:rPr sz="1100" b="0" i="0">
+                <a:solidFill>
+                  <a:srgbClr val="FFFFFF"/>
+                </a:solidFill>
+                <a:latin typeface="Calibri"/>
+              </a:rPr>
+              <a:t>CSE, Amrita Vishwa Vidyapeetham, Amaravati</a:t>
             </a:r>
           </a:p>
         </p:txBody>

</xml_diff>